<commit_message>
Refresh planning pipeline and generated algorithm results
</commit_message>
<xml_diff>
--- a/progress_report/week1.pptx
+++ b/progress_report/week1.pptx
@@ -6,7 +6,7 @@
     <p:sldMasterId id="2147483650" r:id="rId2"/>
   </p:sldMasterIdLst>
   <p:notesMasterIdLst>
-    <p:notesMasterId r:id="rId18"/>
+    <p:notesMasterId r:id="rId17"/>
   </p:notesMasterIdLst>
   <p:sldIdLst>
     <p:sldId id="266" r:id="rId3"/>
@@ -23,7 +23,6 @@
     <p:sldId id="286" r:id="rId14"/>
     <p:sldId id="287" r:id="rId15"/>
     <p:sldId id="288" r:id="rId16"/>
-    <p:sldId id="289" r:id="rId17"/>
   </p:sldIdLst>
   <p:sldSz cx="12192000" cy="6858000"/>
   <p:notesSz cx="6858000" cy="12192000"/>
@@ -986,90 +985,6 @@
             <a:fld id="{F7021451-1387-4CA6-816F-3879F97B5CBC}" type="slidenum">
               <a:rPr lang="en-US"/>
               <a:t>14</a:t>
-            </a:fld>
-            <a:endParaRPr lang="en-US"/>
-          </a:p>
-        </p:txBody>
-      </p:sp>
-    </p:spTree>
-    <p:extLst>
-      <p:ext uri="{BB962C8B-B14F-4D97-AF65-F5344CB8AC3E}">
-        <p14:creationId xmlns:p14="http://schemas.microsoft.com/office/powerpoint/2010/main" val="1024086991"/>
-      </p:ext>
-    </p:extLst>
-  </p:cSld>
-  <p:clrMapOvr>
-    <a:masterClrMapping/>
-  </p:clrMapOvr>
-</p:notes>
-</file>
-
-<file path=ppt/notesSlides/notesSlide15.xml><?xml version="1.0" encoding="utf-8"?>
-<p:notes xmlns:a="http://schemas.openxmlformats.org/drawingml/2006/main" xmlns:r="http://schemas.openxmlformats.org/officeDocument/2006/relationships" xmlns:p="http://schemas.openxmlformats.org/presentationml/2006/main">
-  <p:cSld>
-    <p:spTree>
-      <p:nvGrpSpPr>
-        <p:cNvPr id="1" name=""/>
-        <p:cNvGrpSpPr/>
-        <p:nvPr/>
-      </p:nvGrpSpPr>
-      <p:grpSpPr>
-        <a:xfrm>
-          <a:off x="0" y="0"/>
-          <a:ext cx="0" cy="0"/>
-          <a:chOff x="0" y="0"/>
-          <a:chExt cx="0" cy="0"/>
-        </a:xfrm>
-      </p:grpSpPr>
-      <p:sp>
-        <p:nvSpPr>
-          <p:cNvPr id="2" name="Slide Image Placeholder 1"/>
-          <p:cNvSpPr>
-            <a:spLocks noGrp="1" noRot="1" noChangeAspect="1"/>
-          </p:cNvSpPr>
-          <p:nvPr>
-            <p:ph type="sldImg"/>
-          </p:nvPr>
-        </p:nvSpPr>
-        <p:spPr/>
-      </p:sp>
-      <p:sp>
-        <p:nvSpPr>
-          <p:cNvPr id="3" name="Notes Placeholder 2"/>
-          <p:cNvSpPr>
-            <a:spLocks noGrp="1"/>
-          </p:cNvSpPr>
-          <p:nvPr>
-            <p:ph type="body" idx="1"/>
-          </p:nvPr>
-        </p:nvSpPr>
-        <p:spPr/>
-        <p:txBody>
-          <a:bodyPr/>
-          <a:lstStyle/>
-          <a:p>
-            <a:endParaRPr lang="en-US" dirty="0"/>
-          </a:p>
-        </p:txBody>
-      </p:sp>
-      <p:sp>
-        <p:nvSpPr>
-          <p:cNvPr id="4" name="Slide Number Placeholder 3"/>
-          <p:cNvSpPr>
-            <a:spLocks noGrp="1"/>
-          </p:cNvSpPr>
-          <p:nvPr>
-            <p:ph type="sldNum" sz="quarter" idx="10"/>
-          </p:nvPr>
-        </p:nvSpPr>
-        <p:spPr/>
-        <p:txBody>
-          <a:bodyPr/>
-          <a:lstStyle/>
-          <a:p>
-            <a:fld id="{F7021451-1387-4CA6-816F-3879F97B5CBC}" type="slidenum">
-              <a:rPr lang="en-US"/>
-              <a:t>15</a:t>
             </a:fld>
             <a:endParaRPr lang="en-US"/>
           </a:p>
@@ -2848,12 +2763,12 @@
               <a:buNone/>
             </a:pPr>
             <a:r>
-              <a:rPr lang="en-US" sz="2592" b="1" dirty="0">
+              <a:rPr lang="en-US" sz="2592" b="1" dirty="0" err="1">
                 <a:solidFill>
                   <a:srgbClr val="0B1F3A"/>
                 </a:solidFill>
               </a:rPr>
-              <a:t>接下来工作建议</a:t>
+              <a:t>接下来工作</a:t>
             </a:r>
             <a:endParaRPr lang="en-US" sz="2592" dirty="0"/>
           </a:p>
@@ -5440,7 +5355,7 @@
         <p:spPr>
           <a:xfrm>
             <a:off x="571486" y="1371600"/>
-            <a:ext cx="584027" cy="208280"/>
+            <a:ext cx="762014" cy="184150"/>
           </a:xfrm>
           <a:prstGeom prst="rect">
             <a:avLst/>
@@ -5511,7 +5426,7 @@
         <p:spPr>
           <a:xfrm>
             <a:off x="4390916" y="1371600"/>
-            <a:ext cx="584027" cy="208280"/>
+            <a:ext cx="762014" cy="184150"/>
           </a:xfrm>
           <a:prstGeom prst="rect">
             <a:avLst/>
@@ -5582,7 +5497,7 @@
         <p:spPr>
           <a:xfrm>
             <a:off x="8210345" y="1371600"/>
-            <a:ext cx="584027" cy="208280"/>
+            <a:ext cx="703310" cy="184150"/>
           </a:xfrm>
           <a:prstGeom prst="rect">
             <a:avLst/>
@@ -5652,8 +5567,8 @@
         </p:nvSpPr>
         <p:spPr>
           <a:xfrm>
-            <a:off x="571486" y="4000500"/>
-            <a:ext cx="876040" cy="208280"/>
+            <a:off x="571485" y="4000500"/>
+            <a:ext cx="1208453" cy="178435"/>
           </a:xfrm>
           <a:prstGeom prst="rect">
             <a:avLst/>
@@ -6207,450 +6122,6 @@
     <p:extLst>
       <p:ext uri="{BB962C8B-B14F-4D97-AF65-F5344CB8AC3E}">
         <p14:creationId xmlns:p14="http://schemas.microsoft.com/office/powerpoint/2010/main" val="1672973628"/>
-      </p:ext>
-    </p:extLst>
-  </p:cSld>
-  <p:clrMapOvr>
-    <a:masterClrMapping/>
-  </p:clrMapOvr>
-</p:sld>
-</file>
-
-<file path=ppt/slides/slide15.xml><?xml version="1.0" encoding="utf-8"?>
-<p:sld xmlns:a="http://schemas.openxmlformats.org/drawingml/2006/main" xmlns:r="http://schemas.openxmlformats.org/officeDocument/2006/relationships" xmlns:p="http://schemas.openxmlformats.org/presentationml/2006/main">
-  <p:cSld name="Slide 1">
-    <p:spTree>
-      <p:nvGrpSpPr>
-        <p:cNvPr id="1" name=""/>
-        <p:cNvGrpSpPr/>
-        <p:nvPr/>
-      </p:nvGrpSpPr>
-      <p:grpSpPr>
-        <a:xfrm>
-          <a:off x="0" y="0"/>
-          <a:ext cx="0" cy="0"/>
-          <a:chOff x="0" y="0"/>
-          <a:chExt cx="0" cy="0"/>
-        </a:xfrm>
-      </p:grpSpPr>
-      <p:sp>
-        <p:nvSpPr>
-          <p:cNvPr id="2" name="Shape 0"/>
-          <p:cNvSpPr/>
-          <p:nvPr/>
-        </p:nvSpPr>
-        <p:spPr>
-          <a:xfrm>
-            <a:off x="0" y="0"/>
-            <a:ext cx="12191695" cy="6858000"/>
-          </a:xfrm>
-          <a:prstGeom prst="rect">
-            <a:avLst/>
-          </a:prstGeom>
-          <a:solidFill>
-            <a:srgbClr val="F7F8FB"/>
-          </a:solidFill>
-          <a:ln w="12700">
-            <a:solidFill>
-              <a:srgbClr val="FFFFFF">
-                <a:alpha val="0"/>
-              </a:srgbClr>
-            </a:solidFill>
-            <a:prstDash val="solid"/>
-          </a:ln>
-        </p:spPr>
-        <p:txBody>
-          <a:bodyPr/>
-          <a:lstStyle/>
-          <a:p>
-            <a:endParaRPr lang="zh-CN" altLang="en-US"/>
-          </a:p>
-        </p:txBody>
-      </p:sp>
-      <p:sp>
-        <p:nvSpPr>
-          <p:cNvPr id="3" name="Text 1"/>
-          <p:cNvSpPr/>
-          <p:nvPr/>
-        </p:nvSpPr>
-        <p:spPr>
-          <a:xfrm>
-            <a:off x="514337" y="323850"/>
-            <a:ext cx="896280" cy="193040"/>
-          </a:xfrm>
-          <a:prstGeom prst="rect">
-            <a:avLst/>
-          </a:prstGeom>
-          <a:noFill/>
-          <a:ln/>
-        </p:spPr>
-        <p:txBody>
-          <a:bodyPr wrap="square" lIns="0" tIns="0" rIns="0" bIns="0" rtlCol="0" anchor="t"/>
-          <a:lstStyle/>
-          <a:p>
-            <a:pPr marL="0" indent="0" algn="l">
-              <a:buNone/>
-            </a:pPr>
-            <a:r>
-              <a:rPr lang="en-US" sz="1050" b="1" dirty="0">
-                <a:solidFill>
-                  <a:srgbClr val="1F5AA6"/>
-                </a:solidFill>
-                <a:latin typeface="Helvetica Neue" pitchFamily="34" charset="0"/>
-                <a:ea typeface="Helvetica Neue" pitchFamily="34" charset="-122"/>
-                <a:cs typeface="Helvetica Neue" pitchFamily="34" charset="-120"/>
-              </a:rPr>
-              <a:t>14 · 附录图表</a:t>
-            </a:r>
-            <a:endParaRPr lang="en-US" sz="1050" dirty="0"/>
-          </a:p>
-        </p:txBody>
-      </p:sp>
-      <p:sp>
-        <p:nvSpPr>
-          <p:cNvPr id="4" name="Text 2"/>
-          <p:cNvSpPr/>
-          <p:nvPr/>
-        </p:nvSpPr>
-        <p:spPr>
-          <a:xfrm>
-            <a:off x="514337" y="552450"/>
-            <a:ext cx="3645834" cy="477520"/>
-          </a:xfrm>
-          <a:prstGeom prst="rect">
-            <a:avLst/>
-          </a:prstGeom>
-          <a:noFill/>
-          <a:ln/>
-        </p:spPr>
-        <p:txBody>
-          <a:bodyPr wrap="square" lIns="0" tIns="0" rIns="0" bIns="0" rtlCol="0" anchor="t"/>
-          <a:lstStyle/>
-          <a:p>
-            <a:pPr marL="0" indent="0" algn="l">
-              <a:buNone/>
-            </a:pPr>
-            <a:r>
-              <a:rPr lang="en-US" sz="2550" b="1" dirty="0">
-                <a:solidFill>
-                  <a:srgbClr val="071B33"/>
-                </a:solidFill>
-                <a:latin typeface="Helvetica Neue" pitchFamily="34" charset="0"/>
-                <a:ea typeface="Helvetica Neue" pitchFamily="34" charset="-122"/>
-                <a:cs typeface="Helvetica Neue" pitchFamily="34" charset="-120"/>
-              </a:rPr>
-              <a:t>空间节点与拓扑密度展示</a:t>
-            </a:r>
-            <a:endParaRPr lang="en-US" sz="2550" dirty="0"/>
-          </a:p>
-        </p:txBody>
-      </p:sp>
-      <p:sp>
-        <p:nvSpPr>
-          <p:cNvPr id="5" name="Text 3"/>
-          <p:cNvSpPr/>
-          <p:nvPr/>
-        </p:nvSpPr>
-        <p:spPr>
-          <a:xfrm>
-            <a:off x="514337" y="990600"/>
-            <a:ext cx="4724282" cy="223520"/>
-          </a:xfrm>
-          <a:prstGeom prst="rect">
-            <a:avLst/>
-          </a:prstGeom>
-          <a:noFill/>
-          <a:ln/>
-        </p:spPr>
-        <p:txBody>
-          <a:bodyPr wrap="square" lIns="0" tIns="0" rIns="0" bIns="0" rtlCol="0" anchor="t"/>
-          <a:lstStyle/>
-          <a:p>
-            <a:pPr marL="0" indent="0" algn="l">
-              <a:buNone/>
-            </a:pPr>
-            <a:r>
-              <a:rPr lang="en-US" sz="1200" dirty="0">
-                <a:solidFill>
-                  <a:srgbClr val="516173"/>
-                </a:solidFill>
-                <a:latin typeface="Helvetica Neue" pitchFamily="34" charset="0"/>
-                <a:ea typeface="Helvetica Neue" pitchFamily="34" charset="-122"/>
-                <a:cs typeface="Helvetica Neue" pitchFamily="34" charset="-120"/>
-              </a:rPr>
-              <a:t>对外展示空间覆盖、候选点筛选和拓扑连通性，不展开内部实现路径。</a:t>
-            </a:r>
-            <a:endParaRPr lang="en-US" sz="1200" dirty="0"/>
-          </a:p>
-        </p:txBody>
-      </p:sp>
-      <p:sp>
-        <p:nvSpPr>
-          <p:cNvPr id="6" name="Shape 4"/>
-          <p:cNvSpPr/>
-          <p:nvPr/>
-        </p:nvSpPr>
-        <p:spPr>
-          <a:xfrm>
-            <a:off x="514337" y="1257300"/>
-            <a:ext cx="11163022" cy="9525"/>
-          </a:xfrm>
-          <a:prstGeom prst="rect">
-            <a:avLst/>
-          </a:prstGeom>
-          <a:solidFill>
-            <a:srgbClr val="CAD5E2"/>
-          </a:solidFill>
-          <a:ln w="12700">
-            <a:solidFill>
-              <a:srgbClr val="FFFFFF">
-                <a:alpha val="0"/>
-              </a:srgbClr>
-            </a:solidFill>
-            <a:prstDash val="solid"/>
-          </a:ln>
-        </p:spPr>
-        <p:txBody>
-          <a:bodyPr/>
-          <a:lstStyle/>
-          <a:p>
-            <a:endParaRPr lang="zh-CN" altLang="en-US"/>
-          </a:p>
-        </p:txBody>
-      </p:sp>
-      <p:sp>
-        <p:nvSpPr>
-          <p:cNvPr id="7" name="Text 5"/>
-          <p:cNvSpPr/>
-          <p:nvPr/>
-        </p:nvSpPr>
-        <p:spPr>
-          <a:xfrm>
-            <a:off x="571486" y="1371600"/>
-            <a:ext cx="1683103" cy="175895"/>
-          </a:xfrm>
-          <a:prstGeom prst="rect">
-            <a:avLst/>
-          </a:prstGeom>
-          <a:noFill/>
-          <a:ln/>
-        </p:spPr>
-        <p:txBody>
-          <a:bodyPr wrap="square" lIns="0" tIns="0" rIns="0" bIns="0" rtlCol="0" anchor="t"/>
-          <a:lstStyle/>
-          <a:p>
-            <a:pPr marL="0" indent="0" algn="l">
-              <a:buNone/>
-            </a:pPr>
-            <a:r>
-              <a:rPr lang="en-US" sz="1150" b="1" dirty="0">
-                <a:solidFill>
-                  <a:srgbClr val="1352A2"/>
-                </a:solidFill>
-                <a:latin typeface="Helvetica Neue" pitchFamily="34" charset="0"/>
-                <a:ea typeface="Helvetica Neue" pitchFamily="34" charset="-122"/>
-                <a:cs typeface="Helvetica Neue" pitchFamily="34" charset="-120"/>
-              </a:rPr>
-              <a:t>节点与候选点空间分布</a:t>
-            </a:r>
-            <a:endParaRPr lang="en-US" sz="1150" dirty="0"/>
-          </a:p>
-        </p:txBody>
-      </p:sp>
-      <p:sp>
-        <p:nvSpPr>
-          <p:cNvPr id="8" name="Shape 6"/>
-          <p:cNvSpPr/>
-          <p:nvPr/>
-        </p:nvSpPr>
-        <p:spPr>
-          <a:xfrm>
-            <a:off x="571486" y="1600200"/>
-            <a:ext cx="5333867" cy="4019550"/>
-          </a:xfrm>
-          <a:prstGeom prst="rect">
-            <a:avLst/>
-          </a:prstGeom>
-          <a:solidFill>
-            <a:srgbClr val="FFFFFF"/>
-          </a:solidFill>
-          <a:ln w="5080">
-            <a:solidFill>
-              <a:srgbClr val="CDD7E3"/>
-            </a:solidFill>
-            <a:prstDash val="solid"/>
-          </a:ln>
-        </p:spPr>
-        <p:txBody>
-          <a:bodyPr/>
-          <a:lstStyle/>
-          <a:p>
-            <a:endParaRPr lang="zh-CN" altLang="en-US"/>
-          </a:p>
-        </p:txBody>
-      </p:sp>
-      <p:sp>
-        <p:nvSpPr>
-          <p:cNvPr id="9" name="Text 7"/>
-          <p:cNvSpPr/>
-          <p:nvPr/>
-        </p:nvSpPr>
-        <p:spPr>
-          <a:xfrm>
-            <a:off x="6286342" y="1371600"/>
-            <a:ext cx="1231281" cy="228600"/>
-          </a:xfrm>
-          <a:prstGeom prst="rect">
-            <a:avLst/>
-          </a:prstGeom>
-          <a:noFill/>
-          <a:ln/>
-        </p:spPr>
-        <p:txBody>
-          <a:bodyPr wrap="square" lIns="0" tIns="0" rIns="0" bIns="0" rtlCol="0" anchor="t"/>
-          <a:lstStyle/>
-          <a:p>
-            <a:pPr marL="0" indent="0" algn="l">
-              <a:buNone/>
-            </a:pPr>
-            <a:r>
-              <a:rPr lang="en-US" sz="1150" b="1" dirty="0">
-                <a:solidFill>
-                  <a:srgbClr val="1352A2"/>
-                </a:solidFill>
-                <a:latin typeface="Helvetica Neue" pitchFamily="34" charset="0"/>
-                <a:ea typeface="Helvetica Neue" pitchFamily="34" charset="-122"/>
-                <a:cs typeface="Helvetica Neue" pitchFamily="34" charset="-120"/>
-              </a:rPr>
-              <a:t>拓扑链路密度</a:t>
-            </a:r>
-            <a:endParaRPr lang="en-US" sz="1150" dirty="0"/>
-          </a:p>
-        </p:txBody>
-      </p:sp>
-      <p:sp>
-        <p:nvSpPr>
-          <p:cNvPr id="10" name="Shape 8"/>
-          <p:cNvSpPr/>
-          <p:nvPr/>
-        </p:nvSpPr>
-        <p:spPr>
-          <a:xfrm>
-            <a:off x="6286343" y="1600200"/>
-            <a:ext cx="5333867" cy="4019550"/>
-          </a:xfrm>
-          <a:prstGeom prst="rect">
-            <a:avLst/>
-          </a:prstGeom>
-          <a:solidFill>
-            <a:srgbClr val="FFFFFF"/>
-          </a:solidFill>
-          <a:ln w="5080">
-            <a:solidFill>
-              <a:srgbClr val="CDD7E3"/>
-            </a:solidFill>
-            <a:prstDash val="solid"/>
-          </a:ln>
-        </p:spPr>
-        <p:txBody>
-          <a:bodyPr/>
-          <a:lstStyle/>
-          <a:p>
-            <a:endParaRPr lang="zh-CN" altLang="en-US"/>
-          </a:p>
-        </p:txBody>
-      </p:sp>
-      <p:sp>
-        <p:nvSpPr>
-          <p:cNvPr id="11" name="Text 9"/>
-          <p:cNvSpPr/>
-          <p:nvPr/>
-        </p:nvSpPr>
-        <p:spPr>
-          <a:xfrm>
-            <a:off x="514337" y="6404610"/>
-            <a:ext cx="11163022" cy="243840"/>
-          </a:xfrm>
-          <a:prstGeom prst="rect">
-            <a:avLst/>
-          </a:prstGeom>
-          <a:noFill/>
-          <a:ln/>
-        </p:spPr>
-        <p:txBody>
-          <a:bodyPr wrap="square" lIns="0" tIns="0" rIns="0" bIns="0" rtlCol="0" anchor="t"/>
-          <a:lstStyle/>
-          <a:p>
-            <a:pPr marL="0" indent="0" algn="l">
-              <a:buNone/>
-            </a:pPr>
-            <a:r>
-              <a:rPr lang="en-US" sz="900" dirty="0">
-                <a:solidFill>
-                  <a:srgbClr val="6F7F93"/>
-                </a:solidFill>
-                <a:latin typeface="Helvetica Neue" pitchFamily="34" charset="0"/>
-                <a:ea typeface="Helvetica Neue" pitchFamily="34" charset="-122"/>
-                <a:cs typeface="Helvetica Neue" pitchFamily="34" charset="-120"/>
-              </a:rPr>
-              <a:t>短波/超短波智能规划系统 · 空间与拓扑可视化</a:t>
-            </a:r>
-            <a:endParaRPr lang="en-US" sz="900" dirty="0"/>
-          </a:p>
-        </p:txBody>
-      </p:sp>
-      <p:pic>
-        <p:nvPicPr>
-          <p:cNvPr id="9111" name="spatial nodes candidates"/>
-          <p:cNvPicPr>
-            <a:picLocks noChangeAspect="1"/>
-          </p:cNvPicPr>
-          <p:nvPr/>
-        </p:nvPicPr>
-        <p:blipFill>
-          <a:blip r:embed="rId3"/>
-          <a:stretch>
-            <a:fillRect/>
-          </a:stretch>
-        </p:blipFill>
-        <p:spPr>
-          <a:xfrm>
-            <a:off x="571500" y="1600200"/>
-            <a:ext cx="5334000" cy="3333750"/>
-          </a:xfrm>
-          <a:prstGeom prst="rect">
-            <a:avLst/>
-          </a:prstGeom>
-        </p:spPr>
-      </p:pic>
-      <p:pic>
-        <p:nvPicPr>
-          <p:cNvPr id="9112" name="topology density"/>
-          <p:cNvPicPr>
-            <a:picLocks noChangeAspect="1"/>
-          </p:cNvPicPr>
-          <p:nvPr/>
-        </p:nvPicPr>
-        <p:blipFill>
-          <a:blip r:embed="rId4"/>
-          <a:stretch>
-            <a:fillRect/>
-          </a:stretch>
-        </p:blipFill>
-        <p:spPr>
-          <a:xfrm>
-            <a:off x="6286500" y="1600200"/>
-            <a:ext cx="5334000" cy="3333750"/>
-          </a:xfrm>
-          <a:prstGeom prst="rect">
-            <a:avLst/>
-          </a:prstGeom>
-        </p:spPr>
-      </p:pic>
-    </p:spTree>
-    <p:extLst>
-      <p:ext uri="{BB962C8B-B14F-4D97-AF65-F5344CB8AC3E}">
-        <p14:creationId xmlns:p14="http://schemas.microsoft.com/office/powerpoint/2010/main" val="2723823089"/>
       </p:ext>
     </p:extLst>
   </p:cSld>
@@ -14205,11 +13676,14 @@
         </p:spPr>
         <p:txBody>
           <a:bodyPr wrap="square" lIns="254" tIns="254" rIns="254" bIns="254" rtlCol="0" anchor="ctr">
-            <a:normAutofit/>
+            <a:normAutofit fontScale="92500" lnSpcReduction="10000"/>
           </a:bodyPr>
           <a:lstStyle/>
           <a:p>
             <a:pPr marL="0" indent="0">
+              <a:lnSpc>
+                <a:spcPct val="150000"/>
+              </a:lnSpc>
               <a:buNone/>
             </a:pPr>
             <a:r>
@@ -14327,8 +13801,8 @@
         </p:nvSpPr>
         <p:spPr>
           <a:xfrm>
-            <a:off x="6720840" y="5687568"/>
-            <a:ext cx="4206240" cy="118872"/>
+            <a:off x="6473952" y="5568689"/>
+            <a:ext cx="4453128" cy="411479"/>
           </a:xfrm>
           <a:prstGeom prst="rect">
             <a:avLst/>
@@ -14338,7 +13812,7 @@
         </p:spPr>
         <p:txBody>
           <a:bodyPr wrap="square" lIns="254" tIns="254" rIns="254" bIns="254" rtlCol="0" anchor="t">
-            <a:normAutofit fontScale="77500" lnSpcReduction="20000"/>
+            <a:normAutofit/>
           </a:bodyPr>
           <a:lstStyle/>
           <a:p>
@@ -15060,42 +14534,6 @@
               <a:t>python -m pytest tests</a:t>
             </a:r>
             <a:endParaRPr lang="en-US" sz="1020" dirty="0"/>
-          </a:p>
-        </p:txBody>
-      </p:sp>
-      <p:sp>
-        <p:nvSpPr>
-          <p:cNvPr id="21" name="Text 19"/>
-          <p:cNvSpPr/>
-          <p:nvPr/>
-        </p:nvSpPr>
-        <p:spPr>
-          <a:xfrm>
-            <a:off x="3429000" y="3950208"/>
-            <a:ext cx="1005840" cy="155448"/>
-          </a:xfrm>
-          <a:prstGeom prst="rect">
-            <a:avLst/>
-          </a:prstGeom>
-          <a:noFill/>
-          <a:ln/>
-        </p:spPr>
-        <p:txBody>
-          <a:bodyPr wrap="square" lIns="0" tIns="0" rIns="0" bIns="0" rtlCol="0" anchor="ctr"/>
-          <a:lstStyle/>
-          <a:p>
-            <a:pPr marL="0" indent="0">
-              <a:buNone/>
-            </a:pPr>
-            <a:r>
-              <a:rPr lang="en-US" sz="1482" b="1" dirty="0">
-                <a:solidFill>
-                  <a:srgbClr val="2E7D5B"/>
-                </a:solidFill>
-              </a:rPr>
-              <a:t>3 passed</a:t>
-            </a:r>
-            <a:endParaRPr lang="en-US" sz="1482" dirty="0"/>
           </a:p>
         </p:txBody>
       </p:sp>
@@ -17755,7 +17193,7 @@
 
 <file path=ppt/webextensions/taskpanes.xml><?xml version="1.0" encoding="utf-8"?>
 <wetp:taskpanes xmlns:wetp="http://schemas.microsoft.com/office/webextensions/taskpanes/2010/11">
-  <wetp:taskpane dockstate="right" visibility="0" width="743" row="0">
+  <wetp:taskpane dockstate="right" visibility="0" width="525" row="0">
     <wetp:webextensionref xmlns:r="http://schemas.openxmlformats.org/officeDocument/2006/relationships" r:id="rId1"/>
   </wetp:taskpane>
 </wetp:taskpanes>

</xml_diff>